<commit_message>
Apply 20 points partner margin to Halifax EA proposal pricing
Co-authored-by: chchilds <chchilds@users.noreply.github.com>
</commit_message>
<xml_diff>
--- a/output/HALIFAX_HEALTH_CARE_SYSTEMS_INC_EA_Proposal_9327623.pptx
+++ b/output/HALIFAX_HEALTH_CARE_SYSTEMS_INC_EA_Proposal_9327623.pptx
@@ -3342,6 +3342,21 @@
               <a:t>Partner: CDW</a:t>
             </a:r>
           </a:p>
+          <a:p>
+            <a:pPr>
+              <a:spcBef>
+                <a:spcPts val="400"/>
+              </a:spcBef>
+              <a:defRPr sz="1400">
+                <a:solidFill>
+                  <a:srgbClr val="FFFFFF"/>
+                </a:solidFill>
+              </a:defRPr>
+            </a:pPr>
+            <a:r>
+              <a:t>Customer Pricing: Includes 20 points partner margin</a:t>
+            </a:r>
+          </a:p>
         </p:txBody>
       </p:sp>
       <p:sp>
@@ -3374,7 +3389,7 @@
               </a:defRPr>
             </a:pPr>
             <a:r>
-              <a:t>CISCO CONFIDENTIAL | Indicative pricing only — NOT an approved Cisco quote</a:t>
+              <a:t>CISCO CONFIDENTIAL | Customer pricing includes 20 points partner margin</a:t>
             </a:r>
           </a:p>
         </p:txBody>
@@ -3505,7 +3520,7 @@
               </a:defRPr>
             </a:pPr>
             <a:r>
-              <a:t>Deal ID 86069328 | Quote ID 4802559147</a:t>
+              <a:t>Deal ID 86069328 | Quote ID 4802559147 | 20 points margin applied</a:t>
             </a:r>
           </a:p>
         </p:txBody>
@@ -3534,7 +3549,7 @@
           <a:p>
             <a:pPr>
               <a:spcBef>
-                <a:spcPts val="1400"/>
+                <a:spcPts val="0"/>
               </a:spcBef>
               <a:defRPr sz="1400" b="1">
                 <a:solidFill>
@@ -3591,7 +3606,6 @@
               <a:t>  Account : HALIFAX MEDICAL CENTER US</a:t>
             </a:r>
           </a:p>
-          <a:p/>
           <a:p>
             <a:pPr>
               <a:spcBef>
@@ -3885,6 +3899,21 @@
               <a:t>Commitment: Full Term</a:t>
             </a:r>
           </a:p>
+          <a:p>
+            <a:pPr>
+              <a:spcBef>
+                <a:spcPts val="300"/>
+              </a:spcBef>
+              <a:defRPr sz="1000">
+                <a:solidFill>
+                  <a:srgbClr val="58595B"/>
+                </a:solidFill>
+              </a:defRPr>
+            </a:pPr>
+            <a:r>
+              <a:t>Partner Margin: 20 points applied to all pricing</a:t>
+            </a:r>
+          </a:p>
         </p:txBody>
       </p:sp>
       <p:sp>
@@ -3917,7 +3946,7 @@
               </a:defRPr>
             </a:pPr>
             <a:r>
-              <a:t>CISCO CONFIDENTIAL</a:t>
+              <a:t>CISCO CONFIDENTIAL | Customer pricing includes 20 points partner margin</a:t>
             </a:r>
           </a:p>
         </p:txBody>
@@ -4013,7 +4042,7 @@
               </a:defRPr>
             </a:pPr>
             <a:r>
-              <a:t>Financial Summary (Net Pricing)</a:t>
+              <a:t>Financial Summary (Customer Pricing)</a:t>
             </a:r>
           </a:p>
         </p:txBody>
@@ -4048,7 +4077,7 @@
               </a:defRPr>
             </a:pPr>
             <a:r>
-              <a:t>Total Contract Value: $895,852.73</a:t>
+              <a:t>Total Contract Value: $1,075,023.28 | Includes 20 points partner margin</a:t>
             </a:r>
           </a:p>
         </p:txBody>
@@ -4291,7 +4320,7 @@
                         <a:defRPr sz="900" b="0"/>
                       </a:pPr>
                       <a:r>
-                        <a:t>$55,552.46</a:t>
+                        <a:t>$66,662.95</a:t>
                       </a:r>
                     </a:p>
                   </a:txBody>
@@ -4310,7 +4339,7 @@
                         <a:defRPr sz="900" b="0"/>
                       </a:pPr>
                       <a:r>
-                        <a:t>$55,552.46</a:t>
+                        <a:t>$66,662.95</a:t>
                       </a:r>
                     </a:p>
                   </a:txBody>
@@ -4329,7 +4358,7 @@
                         <a:defRPr sz="900" b="0"/>
                       </a:pPr>
                       <a:r>
-                        <a:t>$123,449.52</a:t>
+                        <a:t>$148,139.42</a:t>
                       </a:r>
                     </a:p>
                   </a:txBody>
@@ -4348,7 +4377,7 @@
                         <a:defRPr sz="900" b="0"/>
                       </a:pPr>
                       <a:r>
-                        <a:t>$67,897.06</a:t>
+                        <a:t>$81,476.47</a:t>
                       </a:r>
                     </a:p>
                   </a:txBody>
@@ -4403,7 +4432,7 @@
                         <a:defRPr sz="900" b="0"/>
                       </a:pPr>
                       <a:r>
-                        <a:t>$683,174.03</a:t>
+                        <a:t>$819,808.84</a:t>
                       </a:r>
                     </a:p>
                   </a:txBody>
@@ -4433,7 +4462,7 @@
                         <a:defRPr sz="900" b="0"/>
                       </a:pPr>
                       <a:r>
-                        <a:t>$683,174.03</a:t>
+                        <a:t>$819,808.84</a:t>
                       </a:r>
                     </a:p>
                   </a:txBody>
@@ -4448,7 +4477,7 @@
                         <a:defRPr sz="900" b="0"/>
                       </a:pPr>
                       <a:r>
-                        <a:t>$1,431,129.69</a:t>
+                        <a:t>$1,717,355.63</a:t>
                       </a:r>
                     </a:p>
                   </a:txBody>
@@ -4463,7 +4492,7 @@
                         <a:defRPr sz="900" b="0"/>
                       </a:pPr>
                       <a:r>
-                        <a:t>$747,955.66</a:t>
+                        <a:t>$897,546.79</a:t>
                       </a:r>
                     </a:p>
                   </a:txBody>
@@ -4514,7 +4543,7 @@
                         <a:defRPr sz="900" b="0"/>
                       </a:pPr>
                       <a:r>
-                        <a:t>$157,126.24</a:t>
+                        <a:t>$188,551.49</a:t>
                       </a:r>
                     </a:p>
                   </a:txBody>
@@ -4552,7 +4581,7 @@
                         <a:defRPr sz="900" b="0"/>
                       </a:pPr>
                       <a:r>
-                        <a:t>$157,126.24</a:t>
+                        <a:t>$188,551.49</a:t>
                       </a:r>
                     </a:p>
                   </a:txBody>
@@ -4571,7 +4600,7 @@
                         <a:defRPr sz="900" b="0"/>
                       </a:pPr>
                       <a:r>
-                        <a:t>$822,998.47</a:t>
+                        <a:t>$987,598.16</a:t>
                       </a:r>
                     </a:p>
                   </a:txBody>
@@ -4590,7 +4619,7 @@
                         <a:defRPr sz="900" b="0"/>
                       </a:pPr>
                       <a:r>
-                        <a:t>$575,946.45</a:t>
+                        <a:t>$691,135.74</a:t>
                       </a:r>
                     </a:p>
                   </a:txBody>
@@ -4609,7 +4638,7 @@
                         <a:defRPr sz="900" b="1"/>
                       </a:pPr>
                       <a:r>
-                        <a:t>$89,925.78</a:t>
+                        <a:t>$107,910.94</a:t>
                       </a:r>
                     </a:p>
                   </a:txBody>
@@ -4645,7 +4674,7 @@
                         <a:defRPr sz="900" b="0"/>
                       </a:pPr>
                       <a:r>
-                        <a:t>$840,300.27</a:t>
+                        <a:t>$1,008,360.32</a:t>
                       </a:r>
                     </a:p>
                   </a:txBody>
@@ -4660,7 +4689,7 @@
                         <a:defRPr sz="900" b="0"/>
                       </a:pPr>
                       <a:r>
-                        <a:t>$55,552.46</a:t>
+                        <a:t>$66,662.95</a:t>
                       </a:r>
                     </a:p>
                   </a:txBody>
@@ -4675,7 +4704,7 @@
                         <a:defRPr sz="900" b="0"/>
                       </a:pPr>
                       <a:r>
-                        <a:t>$895,852.73</a:t>
+                        <a:t>$1,075,023.28</a:t>
                       </a:r>
                     </a:p>
                   </a:txBody>
@@ -4690,7 +4719,7 @@
                         <a:defRPr sz="900" b="0"/>
                       </a:pPr>
                       <a:r>
-                        <a:t>$2,377,577.68</a:t>
+                        <a:t>$2,853,093.22</a:t>
                       </a:r>
                     </a:p>
                   </a:txBody>
@@ -4705,7 +4734,7 @@
                         <a:defRPr sz="900" b="0"/>
                       </a:pPr>
                       <a:r>
-                        <a:t>$1,391,799.17</a:t>
+                        <a:t>$1,670,159.00</a:t>
                       </a:r>
                     </a:p>
                   </a:txBody>
@@ -4720,7 +4749,7 @@
                         <a:defRPr sz="900" b="1"/>
                       </a:pPr>
                       <a:r>
-                        <a:t>$89,925.78</a:t>
+                        <a:t>$107,910.94</a:t>
                       </a:r>
                     </a:p>
                   </a:txBody>
@@ -4761,7 +4790,7 @@
               </a:defRPr>
             </a:pPr>
             <a:r>
-              <a:t>CISCO CONFIDENTIAL</a:t>
+              <a:t>CISCO CONFIDENTIAL | Customer pricing includes 20 points partner margin</a:t>
             </a:r>
           </a:p>
         </p:txBody>
@@ -4775,7 +4804,7 @@
         <p:spPr>
           <a:xfrm>
             <a:off x="365760" y="5303520"/>
-            <a:ext cx="4114800" cy="914400"/>
+            <a:ext cx="4754880" cy="914400"/>
           </a:xfrm>
           <a:prstGeom prst="roundRect">
             <a:avLst/>
@@ -4813,7 +4842,7 @@
               </a:defRPr>
             </a:pPr>
             <a:r>
-              <a:t>Total EA Contract Value: $895,852.73</a:t>
+              <a:t>Total EA Contract Value: $1,075,023.28</a:t>
             </a:r>
           </a:p>
           <a:p>
@@ -4825,7 +4854,7 @@
               </a:defRPr>
             </a:pPr>
             <a:r>
-              <a:t>Total Savings vs. List Price: $1,481,724.95 (62.3%)</a:t>
+              <a:t>Total Savings vs. List Price: $1,778,069.94 (62.3%)</a:t>
             </a:r>
           </a:p>
         </p:txBody>
@@ -4956,7 +4985,7 @@
               </a:defRPr>
             </a:pPr>
             <a:r>
-              <a:t>Portfolio TCV: $683,174.03 | Duration: ~49.5 months | Billing: Annual</a:t>
+              <a:t>Portfolio TCV: $819,808.84 | Includes 20 points margin</a:t>
             </a:r>
           </a:p>
         </p:txBody>
@@ -5094,7 +5123,7 @@
                         </a:defRPr>
                       </a:pPr>
                       <a:r>
-                        <a:t>Unit List/Mo</a:t>
+                        <a:t>Unit/Mo</a:t>
                       </a:r>
                     </a:p>
                   </a:txBody>
@@ -5356,7 +5385,7 @@
                         <a:defRPr sz="900" b="0"/>
                       </a:pPr>
                       <a:r>
-                        <a:t>$76.31</a:t>
+                        <a:t>$91.57</a:t>
                       </a:r>
                     </a:p>
                   </a:txBody>
@@ -5386,7 +5415,7 @@
                         <a:defRPr sz="900" b="1"/>
                       </a:pPr>
                       <a:r>
-                        <a:t>$445,559.03</a:t>
+                        <a:t>$534,670.84</a:t>
                       </a:r>
                     </a:p>
                   </a:txBody>
@@ -5479,7 +5508,7 @@
                         <a:defRPr sz="900" b="0"/>
                       </a:pPr>
                       <a:r>
-                        <a:t>$27.00</a:t>
+                        <a:t>$32.40</a:t>
                       </a:r>
                     </a:p>
                   </a:txBody>
@@ -5517,7 +5546,7 @@
                         <a:defRPr sz="900" b="1"/>
                       </a:pPr>
                       <a:r>
-                        <a:t>$6,305.08</a:t>
+                        <a:t>$7,566.10</a:t>
                       </a:r>
                     </a:p>
                   </a:txBody>
@@ -5721,7 +5750,7 @@
                         <a:defRPr sz="900" b="0"/>
                       </a:pPr>
                       <a:r>
-                        <a:t>$38.37</a:t>
+                        <a:t>$46.04</a:t>
                       </a:r>
                     </a:p>
                   </a:txBody>
@@ -5759,7 +5788,7 @@
                         <a:defRPr sz="900" b="1"/>
                       </a:pPr>
                       <a:r>
-                        <a:t>$231,309.92</a:t>
+                        <a:t>$277,571.90</a:t>
                       </a:r>
                     </a:p>
                   </a:txBody>
@@ -5911,7 +5940,7 @@
               </a:defRPr>
             </a:pPr>
             <a:r>
-              <a:t>CISCO CONFIDENTIAL</a:t>
+              <a:t>CISCO CONFIDENTIAL | Customer pricing includes 20 points partner margin</a:t>
             </a:r>
           </a:p>
         </p:txBody>
@@ -6042,7 +6071,7 @@
               </a:defRPr>
             </a:pPr>
             <a:r>
-              <a:t>Portfolio Software TCV: $157,126.24 | SCU Count: 100</a:t>
+              <a:t>Portfolio Software TCV: $188,551.49 | Includes 20 points margin</a:t>
             </a:r>
           </a:p>
         </p:txBody>
@@ -6180,7 +6209,7 @@
                         </a:defRPr>
                       </a:pPr>
                       <a:r>
-                        <a:t>Unit List/Mo</a:t>
+                        <a:t>Unit/Mo</a:t>
                       </a:r>
                     </a:p>
                   </a:txBody>
@@ -6323,7 +6352,7 @@
                         <a:defRPr sz="900" b="0"/>
                       </a:pPr>
                       <a:r>
-                        <a:t>$1.05</a:t>
+                        <a:t>$1.26</a:t>
                       </a:r>
                     </a:p>
                   </a:txBody>
@@ -6361,7 +6390,7 @@
                         <a:defRPr sz="900" b="1"/>
                       </a:pPr>
                       <a:r>
-                        <a:t>$69,167.31</a:t>
+                        <a:t>$83,000.77</a:t>
                       </a:r>
                     </a:p>
                   </a:txBody>
@@ -6565,7 +6594,7 @@
                         <a:defRPr sz="900" b="0"/>
                       </a:pPr>
                       <a:r>
-                        <a:t>$0.62</a:t>
+                        <a:t>$0.74</a:t>
                       </a:r>
                     </a:p>
                   </a:txBody>
@@ -6603,7 +6632,7 @@
                         <a:defRPr sz="900" b="1"/>
                       </a:pPr>
                       <a:r>
-                        <a:t>$82,193.20</a:t>
+                        <a:t>$98,631.84</a:t>
                       </a:r>
                     </a:p>
                   </a:txBody>
@@ -6684,7 +6713,7 @@
                         <a:defRPr sz="900" b="0"/>
                       </a:pPr>
                       <a:r>
-                        <a:t>$0.12</a:t>
+                        <a:t>$0.14</a:t>
                       </a:r>
                     </a:p>
                   </a:txBody>
@@ -6714,7 +6743,7 @@
                         <a:defRPr sz="900" b="1"/>
                       </a:pPr>
                       <a:r>
-                        <a:t>$5,765.73</a:t>
+                        <a:t>$6,918.88</a:t>
                       </a:r>
                     </a:p>
                   </a:txBody>
@@ -6755,7 +6784,7 @@
               </a:defRPr>
             </a:pPr>
             <a:r>
-              <a:t>CISCO CONFIDENTIAL</a:t>
+              <a:t>CISCO CONFIDENTIAL | Customer pricing includes 20 points partner margin</a:t>
             </a:r>
           </a:p>
         </p:txBody>
@@ -6886,7 +6915,7 @@
               </a:defRPr>
             </a:pPr>
             <a:r>
-              <a:t>Portfolio Services TCV: $55,552.46 | Reseller: CDW LOGISTICS LLC (417691476)</a:t>
+              <a:t>Portfolio Services TCV: $66,662.95 | Includes 20 points margin</a:t>
             </a:r>
           </a:p>
         </p:txBody>
@@ -7205,7 +7234,7 @@
                         <a:defRPr sz="900" b="1"/>
                       </a:pPr>
                       <a:r>
-                        <a:t>$55,552.46</a:t>
+                        <a:t>$66,662.95</a:t>
                       </a:r>
                     </a:p>
                   </a:txBody>
@@ -7250,7 +7279,7 @@
               </a:defRPr>
             </a:pPr>
             <a:r>
-              <a:t>CISCO CONFIDENTIAL</a:t>
+              <a:t>CISCO CONFIDENTIAL | Customer pricing includes 20 points partner margin</a:t>
             </a:r>
           </a:p>
         </p:txBody>
@@ -7381,7 +7410,7 @@
               </a:defRPr>
             </a:pPr>
             <a:r>
-              <a:t>Annual subscription-based Enterprise Agreement</a:t>
+              <a:t>Customer pricing includes 20 points partner margin</a:t>
             </a:r>
           </a:p>
         </p:txBody>
@@ -7450,7 +7479,7 @@
               </a:defRPr>
             </a:pPr>
             <a:r>
-              <a:t>$895,852.73</a:t>
+              <a:t>$1,075,023.28</a:t>
             </a:r>
           </a:p>
         </p:txBody>
@@ -7519,7 +7548,7 @@
               </a:defRPr>
             </a:pPr>
             <a:r>
-              <a:t>$840,300.27</a:t>
+              <a:t>$1,008,360.32</a:t>
             </a:r>
           </a:p>
         </p:txBody>
@@ -7588,7 +7617,7 @@
               </a:defRPr>
             </a:pPr>
             <a:r>
-              <a:t>$55,552.46</a:t>
+              <a:t>$66,662.95</a:t>
             </a:r>
           </a:p>
         </p:txBody>
@@ -7657,7 +7686,7 @@
               </a:defRPr>
             </a:pPr>
             <a:r>
-              <a:t>$2,377,577.68</a:t>
+              <a:t>$2,853,093.22</a:t>
             </a:r>
           </a:p>
         </p:txBody>
@@ -7726,7 +7755,7 @@
               </a:defRPr>
             </a:pPr>
             <a:r>
-              <a:t>$1,391,799.17</a:t>
+              <a:t>$1,670,159.00</a:t>
             </a:r>
           </a:p>
         </p:txBody>
@@ -7795,7 +7824,7 @@
               </a:defRPr>
             </a:pPr>
             <a:r>
-              <a:t>$89,925.78</a:t>
+              <a:t>$107,910.94</a:t>
             </a:r>
           </a:p>
         </p:txBody>
@@ -7830,7 +7859,7 @@
               </a:defRPr>
             </a:pPr>
             <a:r>
-              <a:t>Estimated Average Annual Investment: $217,388.92  (based on ~49.5 month term, annual billing)</a:t>
+              <a:t>Estimated Average Annual Investment: $260,866.70  (includes 20 points margin, ~49.5 month term, annual billing)</a:t>
             </a:r>
           </a:p>
         </p:txBody>
@@ -7865,7 +7894,7 @@
               </a:defRPr>
             </a:pPr>
             <a:r>
-              <a:t>CISCO CONFIDENTIAL</a:t>
+              <a:t>CISCO CONFIDENTIAL | Customer pricing includes 20 points partner margin</a:t>
             </a:r>
           </a:p>
         </p:txBody>
@@ -8072,6 +8101,21 @@
               <a:spcBef>
                 <a:spcPts val="800"/>
               </a:spcBef>
+              <a:defRPr sz="1400" b="1">
+                <a:solidFill>
+                  <a:srgbClr val="005073"/>
+                </a:solidFill>
+              </a:defRPr>
+            </a:pPr>
+            <a:r>
+              <a:t>All dollar amounts shown include 20 points (20%) partner margin applied to Cisco net pricing.</a:t>
+            </a:r>
+          </a:p>
+          <a:p>
+            <a:pPr>
+              <a:spcBef>
+                <a:spcPts val="800"/>
+              </a:spcBef>
               <a:defRPr sz="1200">
                 <a:solidFill>
                   <a:srgbClr val="58595B"/>
@@ -8210,7 +8254,7 @@
               </a:defRPr>
             </a:pPr>
             <a:r>
-              <a:t>CISCO CONFIDENTIAL</a:t>
+              <a:t>CISCO CONFIDENTIAL | Customer pricing includes 20 points partner margin</a:t>
             </a:r>
           </a:p>
         </p:txBody>

</xml_diff>

<commit_message>
Recalculate EA proposal pricing using 20% gross margin (cost ÷ 0.80)
Co-authored-by: chchilds <chchilds@users.noreply.github.com>
</commit_message>
<xml_diff>
--- a/output/HALIFAX_HEALTH_CARE_SYSTEMS_INC_EA_Proposal_9327623.pptx
+++ b/output/HALIFAX_HEALTH_CARE_SYSTEMS_INC_EA_Proposal_9327623.pptx
@@ -3354,7 +3354,7 @@
               </a:defRPr>
             </a:pPr>
             <a:r>
-              <a:t>Customer Pricing: Includes 20 points partner margin</a:t>
+              <a:t>Customer Pricing: Includes 20% gross margin</a:t>
             </a:r>
           </a:p>
         </p:txBody>
@@ -3389,7 +3389,7 @@
               </a:defRPr>
             </a:pPr>
             <a:r>
-              <a:t>CISCO CONFIDENTIAL | Customer pricing includes 20 points partner margin</a:t>
+              <a:t>CISCO CONFIDENTIAL | Customer pricing includes 20% gross margin</a:t>
             </a:r>
           </a:p>
         </p:txBody>
@@ -3520,7 +3520,7 @@
               </a:defRPr>
             </a:pPr>
             <a:r>
-              <a:t>Deal ID 86069328 | Quote ID 4802559147 | 20 points margin applied</a:t>
+              <a:t>Deal ID 86069328 | Quote ID 4802559147 | 20% gross margin</a:t>
             </a:r>
           </a:p>
         </p:txBody>
@@ -3911,7 +3911,7 @@
               </a:defRPr>
             </a:pPr>
             <a:r>
-              <a:t>Partner Margin: 20 points applied to all pricing</a:t>
+              <a:t>Partner Pricing: 20% gross margin (Price = Cost ÷ 0.80)</a:t>
             </a:r>
           </a:p>
         </p:txBody>
@@ -3946,7 +3946,7 @@
               </a:defRPr>
             </a:pPr>
             <a:r>
-              <a:t>CISCO CONFIDENTIAL | Customer pricing includes 20 points partner margin</a:t>
+              <a:t>CISCO CONFIDENTIAL | Customer pricing includes 20% gross margin</a:t>
             </a:r>
           </a:p>
         </p:txBody>
@@ -4077,7 +4077,7 @@
               </a:defRPr>
             </a:pPr>
             <a:r>
-              <a:t>Total Contract Value: $1,075,023.28 | Includes 20 points partner margin</a:t>
+              <a:t>Total Contract Value: $1,119,815.91 | Includes 20% gross margin</a:t>
             </a:r>
           </a:p>
         </p:txBody>
@@ -4320,7 +4320,7 @@
                         <a:defRPr sz="900" b="0"/>
                       </a:pPr>
                       <a:r>
-                        <a:t>$66,662.95</a:t>
+                        <a:t>$69,440.57</a:t>
                       </a:r>
                     </a:p>
                   </a:txBody>
@@ -4339,7 +4339,7 @@
                         <a:defRPr sz="900" b="0"/>
                       </a:pPr>
                       <a:r>
-                        <a:t>$66,662.95</a:t>
+                        <a:t>$69,440.57</a:t>
                       </a:r>
                     </a:p>
                   </a:txBody>
@@ -4358,7 +4358,7 @@
                         <a:defRPr sz="900" b="0"/>
                       </a:pPr>
                       <a:r>
-                        <a:t>$148,139.42</a:t>
+                        <a:t>$154,311.90</a:t>
                       </a:r>
                     </a:p>
                   </a:txBody>
@@ -4377,7 +4377,7 @@
                         <a:defRPr sz="900" b="0"/>
                       </a:pPr>
                       <a:r>
-                        <a:t>$81,476.47</a:t>
+                        <a:t>$84,871.32</a:t>
                       </a:r>
                     </a:p>
                   </a:txBody>
@@ -4432,7 +4432,7 @@
                         <a:defRPr sz="900" b="0"/>
                       </a:pPr>
                       <a:r>
-                        <a:t>$819,808.84</a:t>
+                        <a:t>$853,967.54</a:t>
                       </a:r>
                     </a:p>
                   </a:txBody>
@@ -4462,7 +4462,7 @@
                         <a:defRPr sz="900" b="0"/>
                       </a:pPr>
                       <a:r>
-                        <a:t>$819,808.84</a:t>
+                        <a:t>$853,967.54</a:t>
                       </a:r>
                     </a:p>
                   </a:txBody>
@@ -4477,7 +4477,7 @@
                         <a:defRPr sz="900" b="0"/>
                       </a:pPr>
                       <a:r>
-                        <a:t>$1,717,355.63</a:t>
+                        <a:t>$1,788,912.11</a:t>
                       </a:r>
                     </a:p>
                   </a:txBody>
@@ -4492,7 +4492,7 @@
                         <a:defRPr sz="900" b="0"/>
                       </a:pPr>
                       <a:r>
-                        <a:t>$897,546.79</a:t>
+                        <a:t>$934,944.58</a:t>
                       </a:r>
                     </a:p>
                   </a:txBody>
@@ -4543,7 +4543,7 @@
                         <a:defRPr sz="900" b="0"/>
                       </a:pPr>
                       <a:r>
-                        <a:t>$188,551.49</a:t>
+                        <a:t>$196,407.80</a:t>
                       </a:r>
                     </a:p>
                   </a:txBody>
@@ -4581,7 +4581,7 @@
                         <a:defRPr sz="900" b="0"/>
                       </a:pPr>
                       <a:r>
-                        <a:t>$188,551.49</a:t>
+                        <a:t>$196,407.80</a:t>
                       </a:r>
                     </a:p>
                   </a:txBody>
@@ -4600,7 +4600,7 @@
                         <a:defRPr sz="900" b="0"/>
                       </a:pPr>
                       <a:r>
-                        <a:t>$987,598.16</a:t>
+                        <a:t>$1,028,748.09</a:t>
                       </a:r>
                     </a:p>
                   </a:txBody>
@@ -4619,7 +4619,7 @@
                         <a:defRPr sz="900" b="0"/>
                       </a:pPr>
                       <a:r>
-                        <a:t>$691,135.74</a:t>
+                        <a:t>$719,933.06</a:t>
                       </a:r>
                     </a:p>
                   </a:txBody>
@@ -4638,7 +4638,7 @@
                         <a:defRPr sz="900" b="1"/>
                       </a:pPr>
                       <a:r>
-                        <a:t>$107,910.94</a:t>
+                        <a:t>$112,407.23</a:t>
                       </a:r>
                     </a:p>
                   </a:txBody>
@@ -4674,7 +4674,7 @@
                         <a:defRPr sz="900" b="0"/>
                       </a:pPr>
                       <a:r>
-                        <a:t>$1,008,360.32</a:t>
+                        <a:t>$1,050,375.34</a:t>
                       </a:r>
                     </a:p>
                   </a:txBody>
@@ -4689,7 +4689,7 @@
                         <a:defRPr sz="900" b="0"/>
                       </a:pPr>
                       <a:r>
-                        <a:t>$66,662.95</a:t>
+                        <a:t>$69,440.57</a:t>
                       </a:r>
                     </a:p>
                   </a:txBody>
@@ -4704,7 +4704,7 @@
                         <a:defRPr sz="900" b="0"/>
                       </a:pPr>
                       <a:r>
-                        <a:t>$1,075,023.28</a:t>
+                        <a:t>$1,119,815.91</a:t>
                       </a:r>
                     </a:p>
                   </a:txBody>
@@ -4719,7 +4719,7 @@
                         <a:defRPr sz="900" b="0"/>
                       </a:pPr>
                       <a:r>
-                        <a:t>$2,853,093.22</a:t>
+                        <a:t>$2,971,972.10</a:t>
                       </a:r>
                     </a:p>
                   </a:txBody>
@@ -4734,7 +4734,7 @@
                         <a:defRPr sz="900" b="0"/>
                       </a:pPr>
                       <a:r>
-                        <a:t>$1,670,159.00</a:t>
+                        <a:t>$1,739,748.96</a:t>
                       </a:r>
                     </a:p>
                   </a:txBody>
@@ -4749,7 +4749,7 @@
                         <a:defRPr sz="900" b="1"/>
                       </a:pPr>
                       <a:r>
-                        <a:t>$107,910.94</a:t>
+                        <a:t>$112,407.23</a:t>
                       </a:r>
                     </a:p>
                   </a:txBody>
@@ -4790,7 +4790,7 @@
               </a:defRPr>
             </a:pPr>
             <a:r>
-              <a:t>CISCO CONFIDENTIAL | Customer pricing includes 20 points partner margin</a:t>
+              <a:t>CISCO CONFIDENTIAL | Customer pricing includes 20% gross margin</a:t>
             </a:r>
           </a:p>
         </p:txBody>
@@ -4842,7 +4842,7 @@
               </a:defRPr>
             </a:pPr>
             <a:r>
-              <a:t>Total EA Contract Value: $1,075,023.28</a:t>
+              <a:t>Total EA Contract Value: $1,119,815.91</a:t>
             </a:r>
           </a:p>
           <a:p>
@@ -4854,7 +4854,7 @@
               </a:defRPr>
             </a:pPr>
             <a:r>
-              <a:t>Total Savings vs. List Price: $1,778,069.94 (62.3%)</a:t>
+              <a:t>Total Savings vs. List Price: $1,852,156.19 (62.3%)</a:t>
             </a:r>
           </a:p>
         </p:txBody>
@@ -4985,7 +4985,7 @@
               </a:defRPr>
             </a:pPr>
             <a:r>
-              <a:t>Portfolio TCV: $819,808.84 | Includes 20 points margin</a:t>
+              <a:t>Portfolio TCV: $853,967.54 | Includes 20% gross margin</a:t>
             </a:r>
           </a:p>
         </p:txBody>
@@ -5385,7 +5385,7 @@
                         <a:defRPr sz="900" b="0"/>
                       </a:pPr>
                       <a:r>
-                        <a:t>$91.57</a:t>
+                        <a:t>$95.39</a:t>
                       </a:r>
                     </a:p>
                   </a:txBody>
@@ -5415,7 +5415,7 @@
                         <a:defRPr sz="900" b="1"/>
                       </a:pPr>
                       <a:r>
-                        <a:t>$534,670.84</a:t>
+                        <a:t>$556,948.79</a:t>
                       </a:r>
                     </a:p>
                   </a:txBody>
@@ -5508,7 +5508,7 @@
                         <a:defRPr sz="900" b="0"/>
                       </a:pPr>
                       <a:r>
-                        <a:t>$32.40</a:t>
+                        <a:t>$33.75</a:t>
                       </a:r>
                     </a:p>
                   </a:txBody>
@@ -5546,7 +5546,7 @@
                         <a:defRPr sz="900" b="1"/>
                       </a:pPr>
                       <a:r>
-                        <a:t>$7,566.10</a:t>
+                        <a:t>$7,881.35</a:t>
                       </a:r>
                     </a:p>
                   </a:txBody>
@@ -5750,7 +5750,7 @@
                         <a:defRPr sz="900" b="0"/>
                       </a:pPr>
                       <a:r>
-                        <a:t>$46.04</a:t>
+                        <a:t>$47.96</a:t>
                       </a:r>
                     </a:p>
                   </a:txBody>
@@ -5788,7 +5788,7 @@
                         <a:defRPr sz="900" b="1"/>
                       </a:pPr>
                       <a:r>
-                        <a:t>$277,571.90</a:t>
+                        <a:t>$289,137.40</a:t>
                       </a:r>
                     </a:p>
                   </a:txBody>
@@ -5940,7 +5940,7 @@
               </a:defRPr>
             </a:pPr>
             <a:r>
-              <a:t>CISCO CONFIDENTIAL | Customer pricing includes 20 points partner margin</a:t>
+              <a:t>CISCO CONFIDENTIAL | Customer pricing includes 20% gross margin</a:t>
             </a:r>
           </a:p>
         </p:txBody>
@@ -6071,7 +6071,7 @@
               </a:defRPr>
             </a:pPr>
             <a:r>
-              <a:t>Portfolio Software TCV: $188,551.49 | Includes 20 points margin</a:t>
+              <a:t>Portfolio Software TCV: $196,407.80 | Includes 20% gross margin</a:t>
             </a:r>
           </a:p>
         </p:txBody>
@@ -6352,7 +6352,7 @@
                         <a:defRPr sz="900" b="0"/>
                       </a:pPr>
                       <a:r>
-                        <a:t>$1.26</a:t>
+                        <a:t>$1.31</a:t>
                       </a:r>
                     </a:p>
                   </a:txBody>
@@ -6390,7 +6390,7 @@
                         <a:defRPr sz="900" b="1"/>
                       </a:pPr>
                       <a:r>
-                        <a:t>$83,000.77</a:t>
+                        <a:t>$86,459.14</a:t>
                       </a:r>
                     </a:p>
                   </a:txBody>
@@ -6594,7 +6594,7 @@
                         <a:defRPr sz="900" b="0"/>
                       </a:pPr>
                       <a:r>
-                        <a:t>$0.74</a:t>
+                        <a:t>$0.78</a:t>
                       </a:r>
                     </a:p>
                   </a:txBody>
@@ -6632,7 +6632,7 @@
                         <a:defRPr sz="900" b="1"/>
                       </a:pPr>
                       <a:r>
-                        <a:t>$98,631.84</a:t>
+                        <a:t>$102,741.50</a:t>
                       </a:r>
                     </a:p>
                   </a:txBody>
@@ -6713,7 +6713,7 @@
                         <a:defRPr sz="900" b="0"/>
                       </a:pPr>
                       <a:r>
-                        <a:t>$0.14</a:t>
+                        <a:t>$0.15</a:t>
                       </a:r>
                     </a:p>
                   </a:txBody>
@@ -6743,7 +6743,7 @@
                         <a:defRPr sz="900" b="1"/>
                       </a:pPr>
                       <a:r>
-                        <a:t>$6,918.88</a:t>
+                        <a:t>$7,207.16</a:t>
                       </a:r>
                     </a:p>
                   </a:txBody>
@@ -6784,7 +6784,7 @@
               </a:defRPr>
             </a:pPr>
             <a:r>
-              <a:t>CISCO CONFIDENTIAL | Customer pricing includes 20 points partner margin</a:t>
+              <a:t>CISCO CONFIDENTIAL | Customer pricing includes 20% gross margin</a:t>
             </a:r>
           </a:p>
         </p:txBody>
@@ -6915,7 +6915,7 @@
               </a:defRPr>
             </a:pPr>
             <a:r>
-              <a:t>Portfolio Services TCV: $66,662.95 | Includes 20 points margin</a:t>
+              <a:t>Portfolio Services TCV: $69,440.57 | Includes 20% gross margin</a:t>
             </a:r>
           </a:p>
         </p:txBody>
@@ -7234,7 +7234,7 @@
                         <a:defRPr sz="900" b="1"/>
                       </a:pPr>
                       <a:r>
-                        <a:t>$66,662.95</a:t>
+                        <a:t>$69,440.57</a:t>
                       </a:r>
                     </a:p>
                   </a:txBody>
@@ -7279,7 +7279,7 @@
               </a:defRPr>
             </a:pPr>
             <a:r>
-              <a:t>CISCO CONFIDENTIAL | Customer pricing includes 20 points partner margin</a:t>
+              <a:t>CISCO CONFIDENTIAL | Customer pricing includes 20% gross margin</a:t>
             </a:r>
           </a:p>
         </p:txBody>
@@ -7410,7 +7410,7 @@
               </a:defRPr>
             </a:pPr>
             <a:r>
-              <a:t>Customer pricing includes 20 points partner margin</a:t>
+              <a:t>Customer pricing includes 20% gross margin</a:t>
             </a:r>
           </a:p>
         </p:txBody>
@@ -7479,7 +7479,7 @@
               </a:defRPr>
             </a:pPr>
             <a:r>
-              <a:t>$1,075,023.28</a:t>
+              <a:t>$1,119,815.91</a:t>
             </a:r>
           </a:p>
         </p:txBody>
@@ -7548,7 +7548,7 @@
               </a:defRPr>
             </a:pPr>
             <a:r>
-              <a:t>$1,008,360.32</a:t>
+              <a:t>$1,050,375.34</a:t>
             </a:r>
           </a:p>
         </p:txBody>
@@ -7617,7 +7617,7 @@
               </a:defRPr>
             </a:pPr>
             <a:r>
-              <a:t>$66,662.95</a:t>
+              <a:t>$69,440.57</a:t>
             </a:r>
           </a:p>
         </p:txBody>
@@ -7686,7 +7686,7 @@
               </a:defRPr>
             </a:pPr>
             <a:r>
-              <a:t>$2,853,093.22</a:t>
+              <a:t>$2,971,972.10</a:t>
             </a:r>
           </a:p>
         </p:txBody>
@@ -7755,7 +7755,7 @@
               </a:defRPr>
             </a:pPr>
             <a:r>
-              <a:t>$1,670,159.00</a:t>
+              <a:t>$1,739,748.96</a:t>
             </a:r>
           </a:p>
         </p:txBody>
@@ -7824,7 +7824,7 @@
               </a:defRPr>
             </a:pPr>
             <a:r>
-              <a:t>$107,910.94</a:t>
+              <a:t>$112,407.23</a:t>
             </a:r>
           </a:p>
         </p:txBody>
@@ -7859,7 +7859,7 @@
               </a:defRPr>
             </a:pPr>
             <a:r>
-              <a:t>Estimated Average Annual Investment: $260,866.70  (includes 20 points margin, ~49.5 month term, annual billing)</a:t>
+              <a:t>Estimated Average Annual Investment: $271,736.15  (includes 20% gross margin, ~49.5 month term, annual billing)</a:t>
             </a:r>
           </a:p>
         </p:txBody>
@@ -7894,7 +7894,7 @@
               </a:defRPr>
             </a:pPr>
             <a:r>
-              <a:t>CISCO CONFIDENTIAL | Customer pricing includes 20 points partner margin</a:t>
+              <a:t>CISCO CONFIDENTIAL | Customer pricing includes 20% gross margin</a:t>
             </a:r>
           </a:p>
         </p:txBody>
@@ -8108,7 +8108,7 @@
               </a:defRPr>
             </a:pPr>
             <a:r>
-              <a:t>All dollar amounts shown include 20 points (20%) partner margin applied to Cisco net pricing.</a:t>
+              <a:t>All dollar amounts shown include 20% gross margin applied to Cisco net pricing (Customer Price = Net Cost ÷ 0.80).</a:t>
             </a:r>
           </a:p>
           <a:p>
@@ -8254,7 +8254,7 @@
               </a:defRPr>
             </a:pPr>
             <a:r>
-              <a:t>CISCO CONFIDENTIAL | Customer pricing includes 20 points partner margin</a:t>
+              <a:t>CISCO CONFIDENTIAL | Customer pricing includes 20% gross margin</a:t>
             </a:r>
           </a:p>
         </p:txBody>

</xml_diff>

<commit_message>
Add term TCO slide with 5% growth and 7% inflation
Co-authored-by: chchilds <chchilds@users.noreply.github.com>
</commit_message>
<xml_diff>
--- a/output/HALIFAX_HEALTH_CARE_SYSTEMS_INC_EA_Proposal_9327623.pptx
+++ b/output/HALIFAX_HEALTH_CARE_SYSTEMS_INC_EA_Proposal_9327623.pptx
@@ -12,6 +12,7 @@
     <p:sldId id="260" r:id="rId11"/>
     <p:sldId id="261" r:id="rId12"/>
     <p:sldId id="262" r:id="rId13"/>
+    <p:sldId id="264" r:id="rId15"/>
     <p:sldId id="263" r:id="rId14"/>
   </p:sldIdLst>
   <p:sldSz cx="12191695" cy="6858000" type="screen4x3"/>
@@ -112,6 +113,238 @@
     </a:lvl9pPr>
   </p:defaultTextStyle>
 </p:presentation>
+</file>
+
+<file path=ppt/charts/chart1.xml><?xml version="1.0" encoding="utf-8"?>
+<c:chartSpace xmlns:c="http://schemas.openxmlformats.org/drawingml/2006/chart" xmlns:a="http://schemas.openxmlformats.org/drawingml/2006/main" xmlns:r="http://schemas.openxmlformats.org/officeDocument/2006/relationships">
+  <c:date1904 val="0"/>
+  <c:chart>
+    <c:autoTitleDeleted val="0"/>
+    <c:plotArea>
+      <c:barChart>
+        <c:barDir val="col"/>
+        <c:grouping val="clustered"/>
+        <c:ser>
+          <c:idx val="0"/>
+          <c:order val="0"/>
+          <c:tx>
+            <c:strRef>
+              <c:f>Sheet1!$B$1</c:f>
+              <c:strCache>
+                <c:ptCount val="1"/>
+                <c:pt idx="0">
+                  <c:v>Traditional</c:v>
+                </c:pt>
+              </c:strCache>
+            </c:strRef>
+          </c:tx>
+          <c:spPr>
+            <a:solidFill>
+              <a:srgbClr val="ED8B00"/>
+            </a:solidFill>
+          </c:spPr>
+          <c:cat>
+            <c:strRef>
+              <c:f>Sheet1!$A$2:$A$6</c:f>
+              <c:strCache>
+                <c:ptCount val="5"/>
+                <c:pt idx="0">
+                  <c:v>Year 1</c:v>
+                </c:pt>
+                <c:pt idx="1">
+                  <c:v>Year 2</c:v>
+                </c:pt>
+                <c:pt idx="2">
+                  <c:v>Year 3</c:v>
+                </c:pt>
+                <c:pt idx="3">
+                  <c:v>Year 4</c:v>
+                </c:pt>
+                <c:pt idx="4">
+                  <c:v>Remainder (1.5 mo)</c:v>
+                </c:pt>
+              </c:strCache>
+            </c:strRef>
+          </c:cat>
+          <c:val>
+            <c:numRef>
+              <c:f>Sheet1!$B$2:$B$6</c:f>
+              <c:numCache>
+                <c:formatCode>General</c:formatCode>
+                <c:ptCount val="5"/>
+                <c:pt idx="0">
+                  <c:v>271736.15037181997</c:v>
+                </c:pt>
+                <c:pt idx="1">
+                  <c:v>305295.5649427398</c:v>
+                </c:pt>
+                <c:pt idx="2">
+                  <c:v>342999.5672131682</c:v>
+                </c:pt>
+                <c:pt idx="3">
+                  <c:v>385360.0137639945</c:v>
+                </c:pt>
+                <c:pt idx="4">
+                  <c:v>52373.22283836849</c:v>
+                </c:pt>
+              </c:numCache>
+            </c:numRef>
+          </c:val>
+        </c:ser>
+        <c:ser>
+          <c:idx val="1"/>
+          <c:order val="1"/>
+          <c:tx>
+            <c:strRef>
+              <c:f>Sheet1!$C$1</c:f>
+              <c:strCache>
+                <c:ptCount val="1"/>
+                <c:pt idx="0">
+                  <c:v>Cisco EA</c:v>
+                </c:pt>
+              </c:strCache>
+            </c:strRef>
+          </c:tx>
+          <c:spPr>
+            <a:solidFill>
+              <a:srgbClr val="0097D9"/>
+            </a:solidFill>
+          </c:spPr>
+          <c:cat>
+            <c:strRef>
+              <c:f>Sheet1!$A$2:$A$6</c:f>
+              <c:strCache>
+                <c:ptCount val="5"/>
+                <c:pt idx="0">
+                  <c:v>Year 1</c:v>
+                </c:pt>
+                <c:pt idx="1">
+                  <c:v>Year 2</c:v>
+                </c:pt>
+                <c:pt idx="2">
+                  <c:v>Year 3</c:v>
+                </c:pt>
+                <c:pt idx="3">
+                  <c:v>Year 4</c:v>
+                </c:pt>
+                <c:pt idx="4">
+                  <c:v>Remainder (1.5 mo)</c:v>
+                </c:pt>
+              </c:strCache>
+            </c:strRef>
+          </c:cat>
+          <c:val>
+            <c:numRef>
+              <c:f>Sheet1!$C$2:$C$6</c:f>
+              <c:numCache>
+                <c:formatCode>General</c:formatCode>
+                <c:ptCount val="5"/>
+                <c:pt idx="0">
+                  <c:v>271736.15037181997</c:v>
+                </c:pt>
+                <c:pt idx="1">
+                  <c:v>285322.95789041097</c:v>
+                </c:pt>
+                <c:pt idx="2">
+                  <c:v>299589.1057849315</c:v>
+                </c:pt>
+                <c:pt idx="3">
+                  <c:v>314568.56107417814</c:v>
+                </c:pt>
+                <c:pt idx="4">
+                  <c:v>39955.2809428894</c:v>
+                </c:pt>
+              </c:numCache>
+            </c:numRef>
+          </c:val>
+        </c:ser>
+        <c:axId val="-2068027336"/>
+        <c:axId val="-2113994440"/>
+      </c:barChart>
+      <c:catAx>
+        <c:axId val="-2068027336"/>
+        <c:scaling>
+          <c:orientation val="minMax"/>
+        </c:scaling>
+        <c:delete val="0"/>
+        <c:axPos val="b"/>
+        <c:majorTickMark val="out"/>
+        <c:minorTickMark val="none"/>
+        <c:tickLblPos val="nextTo"/>
+        <c:txPr>
+          <a:bodyPr/>
+          <a:lstStyle/>
+          <a:p>
+            <a:pPr>
+              <a:defRPr sz="800">
+                <a:solidFill>
+                  <a:srgbClr val="58595B"/>
+                </a:solidFill>
+              </a:defRPr>
+            </a:pPr>
+          </a:p>
+        </c:txPr>
+        <c:crossAx val="-2113994440"/>
+        <c:crosses val="autoZero"/>
+        <c:auto val="1"/>
+        <c:lblAlgn val="ctr"/>
+        <c:lblOffset val="100"/>
+        <c:noMultiLvlLbl val="0"/>
+      </c:catAx>
+      <c:valAx>
+        <c:axId val="-2113994440"/>
+        <c:scaling/>
+        <c:delete val="0"/>
+        <c:axPos val="l"/>
+        <c:majorTickMark val="out"/>
+        <c:minorTickMark val="none"/>
+        <c:tickLblPos val="nextTo"/>
+        <c:txPr>
+          <a:bodyPr/>
+          <a:lstStyle/>
+          <a:p>
+            <a:pPr>
+              <a:defRPr sz="800">
+                <a:solidFill>
+                  <a:srgbClr val="58595B"/>
+                </a:solidFill>
+              </a:defRPr>
+            </a:pPr>
+          </a:p>
+        </c:txPr>
+        <c:crossAx val="-2068027336"/>
+        <c:crosses val="autoZero"/>
+      </c:valAx>
+    </c:plotArea>
+    <c:legend>
+      <c:legendPos val="b"/>
+      <c:overlay val="0"/>
+      <c:txPr>
+        <a:bodyPr/>
+        <a:lstStyle/>
+        <a:p>
+          <a:pPr>
+            <a:defRPr sz="900"/>
+          </a:pPr>
+        </a:p>
+      </c:txPr>
+    </c:legend>
+    <c:dispBlanksAs val="gap"/>
+  </c:chart>
+  <c:txPr>
+    <a:bodyPr/>
+    <a:lstStyle/>
+    <a:p>
+      <a:pPr>
+        <a:defRPr sz="1800"/>
+      </a:pPr>
+      <a:endParaRPr lang="en-US"/>
+    </a:p>
+  </c:txPr>
+  <c:externalData r:id="rId1">
+    <c:autoUpdate val="0"/>
+  </c:externalData>
+</c:chartSpace>
 </file>
 
 <file path=ppt/slideLayouts/slideLayout1.xml><?xml version="1.0" encoding="utf-8"?>
@@ -7968,6 +8201,1072 @@
         </p:nvSpPr>
         <p:spPr>
           <a:xfrm>
+            <a:off x="457200" y="164592"/>
+            <a:ext cx="11247120" cy="457200"/>
+          </a:xfrm>
+          <a:prstGeom prst="rect">
+            <a:avLst/>
+          </a:prstGeom>
+          <a:noFill/>
+        </p:spPr>
+        <p:txBody>
+          <a:bodyPr wrap="none">
+            <a:spAutoFit/>
+          </a:bodyPr>
+          <a:lstStyle/>
+          <a:p>
+            <a:pPr>
+              <a:defRPr sz="2600" b="1">
+                <a:solidFill>
+                  <a:srgbClr val="FFFFFF"/>
+                </a:solidFill>
+              </a:defRPr>
+            </a:pPr>
+            <a:r>
+              <a:t>Term TCO Analysis</a:t>
+            </a:r>
+          </a:p>
+        </p:txBody>
+      </p:sp>
+      <p:sp>
+        <p:nvSpPr>
+          <p:cNvPr id="4" name="TextBox 3"/>
+          <p:cNvSpPr txBox="1"/>
+          <p:nvPr/>
+        </p:nvSpPr>
+        <p:spPr>
+          <a:xfrm>
+            <a:off x="457200" y="594360"/>
+            <a:ext cx="11247120" cy="347472"/>
+          </a:xfrm>
+          <a:prstGeom prst="rect">
+            <a:avLst/>
+          </a:prstGeom>
+          <a:noFill/>
+        </p:spPr>
+        <p:txBody>
+          <a:bodyPr wrap="none">
+            <a:spAutoFit/>
+          </a:bodyPr>
+          <a:lstStyle/>
+          <a:p>
+            <a:pPr>
+              <a:defRPr sz="1300">
+                <a:solidFill>
+                  <a:srgbClr val="CCE5F3"/>
+                </a:solidFill>
+              </a:defRPr>
+            </a:pPr>
+            <a:r>
+              <a:t>49.5-month term  |  5% annual growth  |  7% annual inflation  |  20% gross margin</a:t>
+            </a:r>
+          </a:p>
+        </p:txBody>
+      </p:sp>
+      <p:sp>
+        <p:nvSpPr>
+          <p:cNvPr id="5" name="Rounded Rectangle 4"/>
+          <p:cNvSpPr/>
+          <p:nvPr/>
+        </p:nvSpPr>
+        <p:spPr>
+          <a:xfrm>
+            <a:off x="365760" y="1143000"/>
+            <a:ext cx="3749039" cy="1051560"/>
+          </a:xfrm>
+          <a:prstGeom prst="roundRect">
+            <a:avLst/>
+          </a:prstGeom>
+          <a:solidFill>
+            <a:srgbClr val="ED8B00"/>
+          </a:solidFill>
+          <a:ln>
+            <a:noFill/>
+          </a:ln>
+        </p:spPr>
+        <p:style>
+          <a:lnRef idx="1">
+            <a:schemeClr val="accent1"/>
+          </a:lnRef>
+          <a:fillRef idx="3">
+            <a:schemeClr val="accent1"/>
+          </a:fillRef>
+          <a:effectRef idx="2">
+            <a:schemeClr val="accent1"/>
+          </a:effectRef>
+          <a:fontRef idx="minor">
+            <a:schemeClr val="lt1"/>
+          </a:fontRef>
+        </p:style>
+        <p:txBody>
+          <a:bodyPr rtlCol="0" anchor="ctr" wrap="square"/>
+          <a:lstStyle/>
+          <a:p>
+            <a:pPr algn="ctr">
+              <a:defRPr sz="1100">
+                <a:solidFill>
+                  <a:srgbClr val="FFFFFF"/>
+                </a:solidFill>
+              </a:defRPr>
+            </a:pPr>
+            <a:r>
+              <a:t>Traditional TCO</a:t>
+            </a:r>
+          </a:p>
+          <a:p>
+            <a:pPr algn="ctr">
+              <a:defRPr sz="2000" b="1">
+                <a:solidFill>
+                  <a:srgbClr val="FFFFFF"/>
+                </a:solidFill>
+              </a:defRPr>
+            </a:pPr>
+            <a:r>
+              <a:t>$1,357,764.52</a:t>
+            </a:r>
+          </a:p>
+          <a:p>
+            <a:pPr algn="ctr">
+              <a:defRPr sz="900">
+                <a:solidFill>
+                  <a:srgbClr val="FFFFFF"/>
+                </a:solidFill>
+              </a:defRPr>
+            </a:pPr>
+            <a:r>
+              <a:t>5% growth + 7% inflation</a:t>
+            </a:r>
+          </a:p>
+        </p:txBody>
+      </p:sp>
+      <p:sp>
+        <p:nvSpPr>
+          <p:cNvPr id="6" name="Rounded Rectangle 5"/>
+          <p:cNvSpPr/>
+          <p:nvPr/>
+        </p:nvSpPr>
+        <p:spPr>
+          <a:xfrm>
+            <a:off x="4297680" y="1143000"/>
+            <a:ext cx="3749039" cy="1051560"/>
+          </a:xfrm>
+          <a:prstGeom prst="roundRect">
+            <a:avLst/>
+          </a:prstGeom>
+          <a:solidFill>
+            <a:srgbClr val="0097D9"/>
+          </a:solidFill>
+          <a:ln>
+            <a:noFill/>
+          </a:ln>
+        </p:spPr>
+        <p:style>
+          <a:lnRef idx="1">
+            <a:schemeClr val="accent1"/>
+          </a:lnRef>
+          <a:fillRef idx="3">
+            <a:schemeClr val="accent1"/>
+          </a:fillRef>
+          <a:effectRef idx="2">
+            <a:schemeClr val="accent1"/>
+          </a:effectRef>
+          <a:fontRef idx="minor">
+            <a:schemeClr val="lt1"/>
+          </a:fontRef>
+        </p:style>
+        <p:txBody>
+          <a:bodyPr rtlCol="0" anchor="ctr" wrap="square"/>
+          <a:lstStyle/>
+          <a:p>
+            <a:pPr algn="ctr">
+              <a:defRPr sz="1100">
+                <a:solidFill>
+                  <a:srgbClr val="FFFFFF"/>
+                </a:solidFill>
+              </a:defRPr>
+            </a:pPr>
+            <a:r>
+              <a:t>Cisco EA TCO</a:t>
+            </a:r>
+          </a:p>
+          <a:p>
+            <a:pPr algn="ctr">
+              <a:defRPr sz="2000" b="1">
+                <a:solidFill>
+                  <a:srgbClr val="FFFFFF"/>
+                </a:solidFill>
+              </a:defRPr>
+            </a:pPr>
+            <a:r>
+              <a:t>$1,211,172.06</a:t>
+            </a:r>
+          </a:p>
+          <a:p>
+            <a:pPr algn="ctr">
+              <a:defRPr sz="900">
+                <a:solidFill>
+                  <a:srgbClr val="FFFFFF"/>
+                </a:solidFill>
+              </a:defRPr>
+            </a:pPr>
+            <a:r>
+              <a:t>5% growth, prices locked</a:t>
+            </a:r>
+          </a:p>
+        </p:txBody>
+      </p:sp>
+      <p:sp>
+        <p:nvSpPr>
+          <p:cNvPr id="7" name="Rounded Rectangle 6"/>
+          <p:cNvSpPr/>
+          <p:nvPr/>
+        </p:nvSpPr>
+        <p:spPr>
+          <a:xfrm>
+            <a:off x="8229600" y="1143000"/>
+            <a:ext cx="3749039" cy="1051560"/>
+          </a:xfrm>
+          <a:prstGeom prst="roundRect">
+            <a:avLst/>
+          </a:prstGeom>
+          <a:solidFill>
+            <a:srgbClr val="6BBF4A"/>
+          </a:solidFill>
+          <a:ln>
+            <a:noFill/>
+          </a:ln>
+        </p:spPr>
+        <p:style>
+          <a:lnRef idx="1">
+            <a:schemeClr val="accent1"/>
+          </a:lnRef>
+          <a:fillRef idx="3">
+            <a:schemeClr val="accent1"/>
+          </a:fillRef>
+          <a:effectRef idx="2">
+            <a:schemeClr val="accent1"/>
+          </a:effectRef>
+          <a:fontRef idx="minor">
+            <a:schemeClr val="lt1"/>
+          </a:fontRef>
+        </p:style>
+        <p:txBody>
+          <a:bodyPr rtlCol="0" anchor="ctr" wrap="square"/>
+          <a:lstStyle/>
+          <a:p>
+            <a:pPr algn="ctr">
+              <a:defRPr sz="1100">
+                <a:solidFill>
+                  <a:srgbClr val="FFFFFF"/>
+                </a:solidFill>
+              </a:defRPr>
+            </a:pPr>
+            <a:r>
+              <a:t>Inflation-Protection Savings</a:t>
+            </a:r>
+          </a:p>
+          <a:p>
+            <a:pPr algn="ctr">
+              <a:defRPr sz="2000" b="1">
+                <a:solidFill>
+                  <a:srgbClr val="FFFFFF"/>
+                </a:solidFill>
+              </a:defRPr>
+            </a:pPr>
+            <a:r>
+              <a:t>$146,592.46</a:t>
+            </a:r>
+          </a:p>
+          <a:p>
+            <a:pPr algn="ctr">
+              <a:defRPr sz="900">
+                <a:solidFill>
+                  <a:srgbClr val="FFFFFF"/>
+                </a:solidFill>
+              </a:defRPr>
+            </a:pPr>
+            <a:r>
+              <a:t>10.8% lower TCO vs. traditional</a:t>
+            </a:r>
+          </a:p>
+        </p:txBody>
+      </p:sp>
+      <p:graphicFrame>
+        <p:nvGraphicFramePr>
+          <p:cNvPr id="8" name="Table 7"/>
+          <p:cNvGraphicFramePr>
+            <a:graphicFrameLocks noGrp="1"/>
+          </p:cNvGraphicFramePr>
+          <p:nvPr/>
+        </p:nvGraphicFramePr>
+        <p:xfrm>
+          <a:off x="365760" y="2331720"/>
+          <a:ext cx="6766558" cy="2880360"/>
+        </p:xfrm>
+        <a:graphic>
+          <a:graphicData uri="http://schemas.openxmlformats.org/drawingml/2006/table">
+            <a:tbl>
+              <a:tblPr firstRow="1" bandRow="1">
+                <a:tableStyleId>{5C22544A-7EE6-4342-B048-85BDC9FD1C3A}</a:tableStyleId>
+              </a:tblPr>
+              <a:tblGrid>
+                <a:gridCol w="1554480"/>
+                <a:gridCol w="1874519"/>
+                <a:gridCol w="1874519"/>
+                <a:gridCol w="1463040"/>
+              </a:tblGrid>
+              <a:tr h="411480">
+                <a:tc>
+                  <a:txBody>
+                    <a:bodyPr/>
+                    <a:lstStyle/>
+                    <a:p>
+                      <a:pPr algn="ctr">
+                        <a:defRPr sz="900" b="1">
+                          <a:solidFill>
+                            <a:srgbClr val="FFFFFF"/>
+                          </a:solidFill>
+                        </a:defRPr>
+                      </a:pPr>
+                      <a:r>
+                        <a:t>Period</a:t>
+                      </a:r>
+                    </a:p>
+                  </a:txBody>
+                  <a:tcPr anchor="ctr">
+                    <a:solidFill>
+                      <a:srgbClr val="0097D9"/>
+                    </a:solidFill>
+                  </a:tcPr>
+                </a:tc>
+                <a:tc>
+                  <a:txBody>
+                    <a:bodyPr/>
+                    <a:lstStyle/>
+                    <a:p>
+                      <a:pPr algn="ctr">
+                        <a:defRPr sz="900" b="1">
+                          <a:solidFill>
+                            <a:srgbClr val="FFFFFF"/>
+                          </a:solidFill>
+                        </a:defRPr>
+                      </a:pPr>
+                      <a:r>
+                        <a:t>Traditional (Growth + Inflation)</a:t>
+                      </a:r>
+                    </a:p>
+                  </a:txBody>
+                  <a:tcPr anchor="ctr">
+                    <a:solidFill>
+                      <a:srgbClr val="0097D9"/>
+                    </a:solidFill>
+                  </a:tcPr>
+                </a:tc>
+                <a:tc>
+                  <a:txBody>
+                    <a:bodyPr/>
+                    <a:lstStyle/>
+                    <a:p>
+                      <a:pPr algn="ctr">
+                        <a:defRPr sz="900" b="1">
+                          <a:solidFill>
+                            <a:srgbClr val="FFFFFF"/>
+                          </a:solidFill>
+                        </a:defRPr>
+                      </a:pPr>
+                      <a:r>
+                        <a:t>Cisco EA (Growth, Price Lock)</a:t>
+                      </a:r>
+                    </a:p>
+                  </a:txBody>
+                  <a:tcPr anchor="ctr">
+                    <a:solidFill>
+                      <a:srgbClr val="0097D9"/>
+                    </a:solidFill>
+                  </a:tcPr>
+                </a:tc>
+                <a:tc>
+                  <a:txBody>
+                    <a:bodyPr/>
+                    <a:lstStyle/>
+                    <a:p>
+                      <a:pPr algn="ctr">
+                        <a:defRPr sz="900" b="1">
+                          <a:solidFill>
+                            <a:srgbClr val="FFFFFF"/>
+                          </a:solidFill>
+                        </a:defRPr>
+                      </a:pPr>
+                      <a:r>
+                        <a:t>Annual Savings</a:t>
+                      </a:r>
+                    </a:p>
+                  </a:txBody>
+                  <a:tcPr anchor="ctr">
+                    <a:solidFill>
+                      <a:srgbClr val="0097D9"/>
+                    </a:solidFill>
+                  </a:tcPr>
+                </a:tc>
+              </a:tr>
+              <a:tr h="411480">
+                <a:tc>
+                  <a:txBody>
+                    <a:bodyPr/>
+                    <a:lstStyle/>
+                    <a:p>
+                      <a:pPr algn="l">
+                        <a:defRPr sz="900" b="0"/>
+                      </a:pPr>
+                      <a:r>
+                        <a:t>Year 1</a:t>
+                      </a:r>
+                    </a:p>
+                  </a:txBody>
+                  <a:tcPr anchor="ctr">
+                    <a:solidFill>
+                      <a:srgbClr val="F5F5F5"/>
+                    </a:solidFill>
+                  </a:tcPr>
+                </a:tc>
+                <a:tc>
+                  <a:txBody>
+                    <a:bodyPr/>
+                    <a:lstStyle/>
+                    <a:p>
+                      <a:pPr algn="r">
+                        <a:defRPr sz="900" b="0"/>
+                      </a:pPr>
+                      <a:r>
+                        <a:t>$271,736.15</a:t>
+                      </a:r>
+                    </a:p>
+                  </a:txBody>
+                  <a:tcPr anchor="ctr">
+                    <a:solidFill>
+                      <a:srgbClr val="F5F5F5"/>
+                    </a:solidFill>
+                  </a:tcPr>
+                </a:tc>
+                <a:tc>
+                  <a:txBody>
+                    <a:bodyPr/>
+                    <a:lstStyle/>
+                    <a:p>
+                      <a:pPr algn="r">
+                        <a:defRPr sz="900" b="0"/>
+                      </a:pPr>
+                      <a:r>
+                        <a:t>$271,736.15</a:t>
+                      </a:r>
+                    </a:p>
+                  </a:txBody>
+                  <a:tcPr anchor="ctr">
+                    <a:solidFill>
+                      <a:srgbClr val="F5F5F5"/>
+                    </a:solidFill>
+                  </a:tcPr>
+                </a:tc>
+                <a:tc>
+                  <a:txBody>
+                    <a:bodyPr/>
+                    <a:lstStyle/>
+                    <a:p>
+                      <a:pPr algn="r">
+                        <a:defRPr sz="900" b="1"/>
+                      </a:pPr>
+                      <a:r>
+                        <a:t>$0.00</a:t>
+                      </a:r>
+                    </a:p>
+                  </a:txBody>
+                  <a:tcPr anchor="ctr">
+                    <a:solidFill>
+                      <a:srgbClr val="F5F5F5"/>
+                    </a:solidFill>
+                  </a:tcPr>
+                </a:tc>
+              </a:tr>
+              <a:tr h="411480">
+                <a:tc>
+                  <a:txBody>
+                    <a:bodyPr/>
+                    <a:lstStyle/>
+                    <a:p>
+                      <a:pPr algn="l">
+                        <a:defRPr sz="900" b="0"/>
+                      </a:pPr>
+                      <a:r>
+                        <a:t>Year 2</a:t>
+                      </a:r>
+                    </a:p>
+                  </a:txBody>
+                  <a:tcPr anchor="ctr"/>
+                </a:tc>
+                <a:tc>
+                  <a:txBody>
+                    <a:bodyPr/>
+                    <a:lstStyle/>
+                    <a:p>
+                      <a:pPr algn="r">
+                        <a:defRPr sz="900" b="0"/>
+                      </a:pPr>
+                      <a:r>
+                        <a:t>$305,295.56</a:t>
+                      </a:r>
+                    </a:p>
+                  </a:txBody>
+                  <a:tcPr anchor="ctr"/>
+                </a:tc>
+                <a:tc>
+                  <a:txBody>
+                    <a:bodyPr/>
+                    <a:lstStyle/>
+                    <a:p>
+                      <a:pPr algn="r">
+                        <a:defRPr sz="900" b="0"/>
+                      </a:pPr>
+                      <a:r>
+                        <a:t>$285,322.96</a:t>
+                      </a:r>
+                    </a:p>
+                  </a:txBody>
+                  <a:tcPr anchor="ctr"/>
+                </a:tc>
+                <a:tc>
+                  <a:txBody>
+                    <a:bodyPr/>
+                    <a:lstStyle/>
+                    <a:p>
+                      <a:pPr algn="r">
+                        <a:defRPr sz="900" b="1"/>
+                      </a:pPr>
+                      <a:r>
+                        <a:t>$19,972.61</a:t>
+                      </a:r>
+                    </a:p>
+                  </a:txBody>
+                  <a:tcPr anchor="ctr"/>
+                </a:tc>
+              </a:tr>
+              <a:tr h="411480">
+                <a:tc>
+                  <a:txBody>
+                    <a:bodyPr/>
+                    <a:lstStyle/>
+                    <a:p>
+                      <a:pPr algn="l">
+                        <a:defRPr sz="900" b="0"/>
+                      </a:pPr>
+                      <a:r>
+                        <a:t>Year 3</a:t>
+                      </a:r>
+                    </a:p>
+                  </a:txBody>
+                  <a:tcPr anchor="ctr">
+                    <a:solidFill>
+                      <a:srgbClr val="F5F5F5"/>
+                    </a:solidFill>
+                  </a:tcPr>
+                </a:tc>
+                <a:tc>
+                  <a:txBody>
+                    <a:bodyPr/>
+                    <a:lstStyle/>
+                    <a:p>
+                      <a:pPr algn="r">
+                        <a:defRPr sz="900" b="0"/>
+                      </a:pPr>
+                      <a:r>
+                        <a:t>$342,999.57</a:t>
+                      </a:r>
+                    </a:p>
+                  </a:txBody>
+                  <a:tcPr anchor="ctr">
+                    <a:solidFill>
+                      <a:srgbClr val="F5F5F5"/>
+                    </a:solidFill>
+                  </a:tcPr>
+                </a:tc>
+                <a:tc>
+                  <a:txBody>
+                    <a:bodyPr/>
+                    <a:lstStyle/>
+                    <a:p>
+                      <a:pPr algn="r">
+                        <a:defRPr sz="900" b="0"/>
+                      </a:pPr>
+                      <a:r>
+                        <a:t>$299,589.11</a:t>
+                      </a:r>
+                    </a:p>
+                  </a:txBody>
+                  <a:tcPr anchor="ctr">
+                    <a:solidFill>
+                      <a:srgbClr val="F5F5F5"/>
+                    </a:solidFill>
+                  </a:tcPr>
+                </a:tc>
+                <a:tc>
+                  <a:txBody>
+                    <a:bodyPr/>
+                    <a:lstStyle/>
+                    <a:p>
+                      <a:pPr algn="r">
+                        <a:defRPr sz="900" b="1"/>
+                      </a:pPr>
+                      <a:r>
+                        <a:t>$43,410.46</a:t>
+                      </a:r>
+                    </a:p>
+                  </a:txBody>
+                  <a:tcPr anchor="ctr">
+                    <a:solidFill>
+                      <a:srgbClr val="F5F5F5"/>
+                    </a:solidFill>
+                  </a:tcPr>
+                </a:tc>
+              </a:tr>
+              <a:tr h="411480">
+                <a:tc>
+                  <a:txBody>
+                    <a:bodyPr/>
+                    <a:lstStyle/>
+                    <a:p>
+                      <a:pPr algn="l">
+                        <a:defRPr sz="900" b="0"/>
+                      </a:pPr>
+                      <a:r>
+                        <a:t>Year 4</a:t>
+                      </a:r>
+                    </a:p>
+                  </a:txBody>
+                  <a:tcPr anchor="ctr"/>
+                </a:tc>
+                <a:tc>
+                  <a:txBody>
+                    <a:bodyPr/>
+                    <a:lstStyle/>
+                    <a:p>
+                      <a:pPr algn="r">
+                        <a:defRPr sz="900" b="0"/>
+                      </a:pPr>
+                      <a:r>
+                        <a:t>$385,360.01</a:t>
+                      </a:r>
+                    </a:p>
+                  </a:txBody>
+                  <a:tcPr anchor="ctr"/>
+                </a:tc>
+                <a:tc>
+                  <a:txBody>
+                    <a:bodyPr/>
+                    <a:lstStyle/>
+                    <a:p>
+                      <a:pPr algn="r">
+                        <a:defRPr sz="900" b="0"/>
+                      </a:pPr>
+                      <a:r>
+                        <a:t>$314,568.56</a:t>
+                      </a:r>
+                    </a:p>
+                  </a:txBody>
+                  <a:tcPr anchor="ctr"/>
+                </a:tc>
+                <a:tc>
+                  <a:txBody>
+                    <a:bodyPr/>
+                    <a:lstStyle/>
+                    <a:p>
+                      <a:pPr algn="r">
+                        <a:defRPr sz="900" b="1"/>
+                      </a:pPr>
+                      <a:r>
+                        <a:t>$70,791.45</a:t>
+                      </a:r>
+                    </a:p>
+                  </a:txBody>
+                  <a:tcPr anchor="ctr"/>
+                </a:tc>
+              </a:tr>
+              <a:tr h="411480">
+                <a:tc>
+                  <a:txBody>
+                    <a:bodyPr/>
+                    <a:lstStyle/>
+                    <a:p>
+                      <a:pPr algn="l">
+                        <a:defRPr sz="900" b="0"/>
+                      </a:pPr>
+                      <a:r>
+                        <a:t>Remainder (1.5 mo)</a:t>
+                      </a:r>
+                    </a:p>
+                  </a:txBody>
+                  <a:tcPr anchor="ctr">
+                    <a:solidFill>
+                      <a:srgbClr val="F5F5F5"/>
+                    </a:solidFill>
+                  </a:tcPr>
+                </a:tc>
+                <a:tc>
+                  <a:txBody>
+                    <a:bodyPr/>
+                    <a:lstStyle/>
+                    <a:p>
+                      <a:pPr algn="r">
+                        <a:defRPr sz="900" b="0"/>
+                      </a:pPr>
+                      <a:r>
+                        <a:t>$52,373.22</a:t>
+                      </a:r>
+                    </a:p>
+                  </a:txBody>
+                  <a:tcPr anchor="ctr">
+                    <a:solidFill>
+                      <a:srgbClr val="F5F5F5"/>
+                    </a:solidFill>
+                  </a:tcPr>
+                </a:tc>
+                <a:tc>
+                  <a:txBody>
+                    <a:bodyPr/>
+                    <a:lstStyle/>
+                    <a:p>
+                      <a:pPr algn="r">
+                        <a:defRPr sz="900" b="0"/>
+                      </a:pPr>
+                      <a:r>
+                        <a:t>$39,955.28</a:t>
+                      </a:r>
+                    </a:p>
+                  </a:txBody>
+                  <a:tcPr anchor="ctr">
+                    <a:solidFill>
+                      <a:srgbClr val="F5F5F5"/>
+                    </a:solidFill>
+                  </a:tcPr>
+                </a:tc>
+                <a:tc>
+                  <a:txBody>
+                    <a:bodyPr/>
+                    <a:lstStyle/>
+                    <a:p>
+                      <a:pPr algn="r">
+                        <a:defRPr sz="900" b="1"/>
+                      </a:pPr>
+                      <a:r>
+                        <a:t>$12,417.94</a:t>
+                      </a:r>
+                    </a:p>
+                  </a:txBody>
+                  <a:tcPr anchor="ctr">
+                    <a:solidFill>
+                      <a:srgbClr val="F5F5F5"/>
+                    </a:solidFill>
+                  </a:tcPr>
+                </a:tc>
+              </a:tr>
+              <a:tr h="411480">
+                <a:tc>
+                  <a:txBody>
+                    <a:bodyPr/>
+                    <a:lstStyle/>
+                    <a:p>
+                      <a:pPr algn="l">
+                        <a:defRPr sz="900" b="1">
+                          <a:solidFill>
+                            <a:srgbClr val="FFFFFF"/>
+                          </a:solidFill>
+                        </a:defRPr>
+                      </a:pPr>
+                      <a:r>
+                        <a:t>Term Total</a:t>
+                      </a:r>
+                    </a:p>
+                  </a:txBody>
+                  <a:tcPr anchor="ctr">
+                    <a:solidFill>
+                      <a:srgbClr val="005073"/>
+                    </a:solidFill>
+                  </a:tcPr>
+                </a:tc>
+                <a:tc>
+                  <a:txBody>
+                    <a:bodyPr/>
+                    <a:lstStyle/>
+                    <a:p>
+                      <a:pPr algn="r">
+                        <a:defRPr sz="900" b="1">
+                          <a:solidFill>
+                            <a:srgbClr val="FFFFFF"/>
+                          </a:solidFill>
+                        </a:defRPr>
+                      </a:pPr>
+                      <a:r>
+                        <a:t>$1,357,764.52</a:t>
+                      </a:r>
+                    </a:p>
+                  </a:txBody>
+                  <a:tcPr anchor="ctr">
+                    <a:solidFill>
+                      <a:srgbClr val="005073"/>
+                    </a:solidFill>
+                  </a:tcPr>
+                </a:tc>
+                <a:tc>
+                  <a:txBody>
+                    <a:bodyPr/>
+                    <a:lstStyle/>
+                    <a:p>
+                      <a:pPr algn="r">
+                        <a:defRPr sz="900" b="1">
+                          <a:solidFill>
+                            <a:srgbClr val="FFFFFF"/>
+                          </a:solidFill>
+                        </a:defRPr>
+                      </a:pPr>
+                      <a:r>
+                        <a:t>$1,211,172.06</a:t>
+                      </a:r>
+                    </a:p>
+                  </a:txBody>
+                  <a:tcPr anchor="ctr">
+                    <a:solidFill>
+                      <a:srgbClr val="005073"/>
+                    </a:solidFill>
+                  </a:tcPr>
+                </a:tc>
+                <a:tc>
+                  <a:txBody>
+                    <a:bodyPr/>
+                    <a:lstStyle/>
+                    <a:p>
+                      <a:pPr algn="r">
+                        <a:defRPr sz="900" b="1">
+                          <a:solidFill>
+                            <a:srgbClr val="FFFFFF"/>
+                          </a:solidFill>
+                        </a:defRPr>
+                      </a:pPr>
+                      <a:r>
+                        <a:t>$146,592.46</a:t>
+                      </a:r>
+                    </a:p>
+                  </a:txBody>
+                  <a:tcPr anchor="ctr">
+                    <a:solidFill>
+                      <a:srgbClr val="005073"/>
+                    </a:solidFill>
+                  </a:tcPr>
+                </a:tc>
+              </a:tr>
+            </a:tbl>
+          </a:graphicData>
+        </a:graphic>
+      </p:graphicFrame>
+      <p:graphicFrame>
+        <p:nvGraphicFramePr>
+          <p:cNvPr id="9" name="Chart 8"/>
+          <p:cNvGraphicFramePr>
+            <a:graphicFrameLocks noGrp="1"/>
+          </p:cNvGraphicFramePr>
+          <p:nvPr/>
+        </p:nvGraphicFramePr>
+        <p:xfrm>
+          <a:off x="7269480" y="2286000"/>
+          <a:ext cx="4572000" cy="2971800"/>
+        </p:xfrm>
+        <a:graphic>
+          <a:graphicData uri="http://schemas.openxmlformats.org/drawingml/2006/chart">
+            <c:chart xmlns:c="http://schemas.openxmlformats.org/drawingml/2006/chart" r:id="rId2"/>
+          </a:graphicData>
+        </a:graphic>
+      </p:graphicFrame>
+      <p:sp>
+        <p:nvSpPr>
+          <p:cNvPr id="10" name="TextBox 9"/>
+          <p:cNvSpPr txBox="1"/>
+          <p:nvPr/>
+        </p:nvSpPr>
+        <p:spPr>
+          <a:xfrm>
+            <a:off x="365760" y="5285232"/>
+            <a:ext cx="11430000" cy="1078992"/>
+          </a:xfrm>
+          <a:prstGeom prst="rect">
+            <a:avLst/>
+          </a:prstGeom>
+          <a:noFill/>
+        </p:spPr>
+        <p:txBody>
+          <a:bodyPr wrap="square">
+            <a:spAutoFit/>
+          </a:bodyPr>
+          <a:lstStyle/>
+          <a:p>
+            <a:pPr>
+              <a:defRPr sz="1100" b="1">
+                <a:solidFill>
+                  <a:srgbClr val="005073"/>
+                </a:solidFill>
+              </a:defRPr>
+            </a:pPr>
+            <a:r>
+              <a:t>Assumptions</a:t>
+            </a:r>
+          </a:p>
+          <a:p>
+            <a:pPr>
+              <a:spcBef>
+                <a:spcPts val="200"/>
+              </a:spcBef>
+              <a:defRPr sz="900">
+                <a:solidFill>
+                  <a:srgbClr val="58595B"/>
+                </a:solidFill>
+              </a:defRPr>
+            </a:pPr>
+            <a:r>
+              <a:t>Year 1 baseline is the annualized customer TCV ($271,736.15 = $1,119,815.91 × 12 / 49.5 months).</a:t>
+            </a:r>
+          </a:p>
+          <a:p>
+            <a:pPr>
+              <a:spcBef>
+                <a:spcPts val="200"/>
+              </a:spcBef>
+              <a:defRPr sz="900">
+                <a:solidFill>
+                  <a:srgbClr val="58595B"/>
+                </a:solidFill>
+              </a:defRPr>
+            </a:pPr>
+            <a:r>
+              <a:t>Both paths apply 5% annual consumption growth (EA True Forward at locked unit rates). 7% inflation applies only to traditional / a-la-carte purchasing.</a:t>
+            </a:r>
+          </a:p>
+          <a:p>
+            <a:pPr>
+              <a:spcBef>
+                <a:spcPts val="200"/>
+              </a:spcBef>
+              <a:defRPr sz="900">
+                <a:solidFill>
+                  <a:srgbClr val="58595B"/>
+                </a:solidFill>
+              </a:defRPr>
+            </a:pPr>
+            <a:r>
+              <a:t>Quoted EA TCV with no growth is $1,119,815.91. EA TCO above includes True Forward on 5% growth. Remainder is prorated 1.5 months of year 5. Pricing includes 20% gross margin.</a:t>
+            </a:r>
+          </a:p>
+        </p:txBody>
+      </p:sp>
+      <p:sp>
+        <p:nvSpPr>
+          <p:cNvPr id="11" name="TextBox 10"/>
+          <p:cNvSpPr txBox="1"/>
+          <p:nvPr/>
+        </p:nvSpPr>
+        <p:spPr>
+          <a:xfrm>
+            <a:off x="365760" y="6400800"/>
+            <a:ext cx="11430000" cy="320040"/>
+          </a:xfrm>
+          <a:prstGeom prst="rect">
+            <a:avLst/>
+          </a:prstGeom>
+          <a:noFill/>
+        </p:spPr>
+        <p:txBody>
+          <a:bodyPr wrap="none">
+            <a:spAutoFit/>
+          </a:bodyPr>
+          <a:lstStyle/>
+          <a:p>
+            <a:pPr>
+              <a:defRPr sz="900" i="1">
+                <a:solidFill>
+                  <a:srgbClr val="58595B"/>
+                </a:solidFill>
+              </a:defRPr>
+            </a:pPr>
+            <a:r>
+              <a:t>CISCO CONFIDENTIAL | Customer pricing includes 20% gross margin</a:t>
+            </a:r>
+          </a:p>
+        </p:txBody>
+      </p:sp>
+    </p:spTree>
+  </p:cSld>
+  <p:clrMapOvr>
+    <a:masterClrMapping/>
+  </p:clrMapOvr>
+</p:sld>
+</file>
+
+<file path=ppt/slides/slide9.xml><?xml version="1.0" encoding="utf-8"?>
+<p:sld xmlns:a="http://schemas.openxmlformats.org/drawingml/2006/main" xmlns:p="http://schemas.openxmlformats.org/presentationml/2006/main" xmlns:r="http://schemas.openxmlformats.org/officeDocument/2006/relationships">
+  <p:cSld>
+    <p:spTree>
+      <p:nvGrpSpPr>
+        <p:cNvPr id="1" name=""/>
+        <p:cNvGrpSpPr/>
+        <p:nvPr/>
+      </p:nvGrpSpPr>
+      <p:grpSpPr/>
+      <p:sp>
+        <p:nvSpPr>
+          <p:cNvPr id="2" name="Rectangle 1"/>
+          <p:cNvSpPr/>
+          <p:nvPr/>
+        </p:nvSpPr>
+        <p:spPr>
+          <a:xfrm>
+            <a:off x="0" y="0"/>
+            <a:ext cx="12191695" cy="1005840"/>
+          </a:xfrm>
+          <a:prstGeom prst="rect">
+            <a:avLst/>
+          </a:prstGeom>
+          <a:solidFill>
+            <a:srgbClr val="005073"/>
+          </a:solidFill>
+          <a:ln>
+            <a:noFill/>
+          </a:ln>
+        </p:spPr>
+        <p:style>
+          <a:lnRef idx="1">
+            <a:schemeClr val="accent1"/>
+          </a:lnRef>
+          <a:fillRef idx="3">
+            <a:schemeClr val="accent1"/>
+          </a:fillRef>
+          <a:effectRef idx="2">
+            <a:schemeClr val="accent1"/>
+          </a:effectRef>
+          <a:fontRef idx="minor">
+            <a:schemeClr val="lt1"/>
+          </a:fontRef>
+        </p:style>
+        <p:txBody>
+          <a:bodyPr rtlCol="0" anchor="ctr"/>
+          <a:lstStyle/>
+          <a:p>
+            <a:pPr algn="ctr"/>
+          </a:p>
+        </p:txBody>
+      </p:sp>
+      <p:sp>
+        <p:nvSpPr>
+          <p:cNvPr id="3" name="TextBox 2"/>
+          <p:cNvSpPr txBox="1"/>
+          <p:nvPr/>
+        </p:nvSpPr>
+        <p:spPr>
+          <a:xfrm>
             <a:off x="457200" y="182880"/>
             <a:ext cx="10972800" cy="640080"/>
           </a:xfrm>
@@ -8220,6 +9519,21 @@
             </a:pPr>
             <a:r>
               <a:t>Deal ID: 86069328 | Quote ID: 4802559147</a:t>
+            </a:r>
+          </a:p>
+          <a:p>
+            <a:pPr>
+              <a:spcBef>
+                <a:spcPts val="600"/>
+              </a:spcBef>
+              <a:defRPr sz="1300" b="1">
+                <a:solidFill>
+                  <a:srgbClr val="005073"/>
+                </a:solidFill>
+              </a:defRPr>
+            </a:pPr>
+            <a:r>
+              <a:t>TCO figures are illustrative. Growth (5%) and inflation (7%) are modeling assumptions, not contractual commitments. Actual True Forward is based on measured consumption at anniversary.</a:t>
             </a:r>
           </a:p>
         </p:txBody>

</xml_diff>